<commit_message>
Eğitim: klasör yapısı, sunum şablonları sayfası, büyük önizlemeler, toplu zip indirme; çıkış bağlantısı düzeltmesi
Co-Authored-By: Claude Sonnet 5.5 <noreply@anthropic.com>
Claude-Session: https://claude.ai/code/session_01XfzShygqwZfMbhNHBGEvwb
</commit_message>
<xml_diff>
--- a/egitim/dosyalar/Sunum-Sablonu-Cerceve-01.pptx
+++ b/egitim/dosyalar/Sunum-Sablonu-Cerceve-01.pptx
@@ -3830,646 +3830,6 @@
 </p:sld>
 </file>
 
-<file path=ppt/slides/slide13.xml><?xml version="1.0" encoding="utf-8"?>
-<p:sld xmlns:a="http://schemas.openxmlformats.org/drawingml/2006/main" xmlns:p="http://schemas.openxmlformats.org/presentationml/2006/main" xmlns:r="http://schemas.openxmlformats.org/officeDocument/2006/relationships">
-  <p:cSld>
-    <p:bg>
-      <p:bgPr>
-        <a:solidFill>
-          <a:srgbClr val="6E1023"/>
-        </a:solidFill>
-        <a:effectLst/>
-      </p:bgPr>
-    </p:bg>
-    <p:spTree>
-      <p:nvGrpSpPr>
-        <p:cNvPr id="1" name=""/>
-        <p:cNvGrpSpPr/>
-        <p:nvPr/>
-      </p:nvGrpSpPr>
-      <p:grpSpPr/>
-      <p:sp>
-        <p:nvSpPr>
-          <p:cNvPr id="2" name="Rectangle 1"/>
-          <p:cNvSpPr/>
-          <p:nvPr/>
-        </p:nvSpPr>
-        <p:spPr>
-          <a:xfrm>
-            <a:off x="365760" y="1097280"/>
-            <a:ext cx="566928" cy="566928"/>
-          </a:xfrm>
-          <a:prstGeom prst="rect">
-            <a:avLst/>
-          </a:prstGeom>
-          <a:solidFill>
-            <a:srgbClr val="FFFFFF">
-              <a:alpha val="10000"/>
-            </a:srgbClr>
-          </a:solidFill>
-          <a:ln>
-            <a:noFill/>
-          </a:ln>
-          <a:effectLst/>
-        </p:spPr>
-        <p:style>
-          <a:lnRef idx="1">
-            <a:schemeClr val="accent1"/>
-          </a:lnRef>
-          <a:fillRef idx="3">
-            <a:schemeClr val="accent1"/>
-          </a:fillRef>
-          <a:effectRef idx="2">
-            <a:schemeClr val="accent1"/>
-          </a:effectRef>
-          <a:fontRef idx="minor">
-            <a:schemeClr val="lt1"/>
-          </a:fontRef>
-        </p:style>
-        <p:txBody>
-          <a:bodyPr rtlCol="0" anchor="ctr"/>
-          <a:lstStyle/>
-          <a:p>
-            <a:pPr algn="ctr"/>
-          </a:p>
-        </p:txBody>
-      </p:sp>
-      <p:sp>
-        <p:nvSpPr>
-          <p:cNvPr id="3" name="Rectangle 2"/>
-          <p:cNvSpPr/>
-          <p:nvPr/>
-        </p:nvSpPr>
-        <p:spPr>
-          <a:xfrm>
-            <a:off x="365760" y="1737360"/>
-            <a:ext cx="566928" cy="566928"/>
-          </a:xfrm>
-          <a:prstGeom prst="rect">
-            <a:avLst/>
-          </a:prstGeom>
-          <a:solidFill>
-            <a:srgbClr val="FFFFFF">
-              <a:alpha val="16000"/>
-            </a:srgbClr>
-          </a:solidFill>
-          <a:ln>
-            <a:noFill/>
-          </a:ln>
-          <a:effectLst/>
-        </p:spPr>
-        <p:style>
-          <a:lnRef idx="1">
-            <a:schemeClr val="accent1"/>
-          </a:lnRef>
-          <a:fillRef idx="3">
-            <a:schemeClr val="accent1"/>
-          </a:fillRef>
-          <a:effectRef idx="2">
-            <a:schemeClr val="accent1"/>
-          </a:effectRef>
-          <a:fontRef idx="minor">
-            <a:schemeClr val="lt1"/>
-          </a:fontRef>
-        </p:style>
-        <p:txBody>
-          <a:bodyPr rtlCol="0" anchor="ctr"/>
-          <a:lstStyle/>
-          <a:p>
-            <a:pPr algn="ctr"/>
-          </a:p>
-        </p:txBody>
-      </p:sp>
-      <p:sp>
-        <p:nvSpPr>
-          <p:cNvPr id="4" name="Rectangle 3"/>
-          <p:cNvSpPr/>
-          <p:nvPr/>
-        </p:nvSpPr>
-        <p:spPr>
-          <a:xfrm>
-            <a:off x="1005840" y="1737360"/>
-            <a:ext cx="566928" cy="566928"/>
-          </a:xfrm>
-          <a:prstGeom prst="rect">
-            <a:avLst/>
-          </a:prstGeom>
-          <a:solidFill>
-            <a:srgbClr val="FFFFFF">
-              <a:alpha val="8000"/>
-            </a:srgbClr>
-          </a:solidFill>
-          <a:ln>
-            <a:noFill/>
-          </a:ln>
-          <a:effectLst/>
-        </p:spPr>
-        <p:style>
-          <a:lnRef idx="1">
-            <a:schemeClr val="accent1"/>
-          </a:lnRef>
-          <a:fillRef idx="3">
-            <a:schemeClr val="accent1"/>
-          </a:fillRef>
-          <a:effectRef idx="2">
-            <a:schemeClr val="accent1"/>
-          </a:effectRef>
-          <a:fontRef idx="minor">
-            <a:schemeClr val="lt1"/>
-          </a:fontRef>
-        </p:style>
-        <p:txBody>
-          <a:bodyPr rtlCol="0" anchor="ctr"/>
-          <a:lstStyle/>
-          <a:p>
-            <a:pPr algn="ctr"/>
-          </a:p>
-        </p:txBody>
-      </p:sp>
-      <p:sp>
-        <p:nvSpPr>
-          <p:cNvPr id="5" name="Rectangle 4"/>
-          <p:cNvSpPr/>
-          <p:nvPr/>
-        </p:nvSpPr>
-        <p:spPr>
-          <a:xfrm>
-            <a:off x="365760" y="4206240"/>
-            <a:ext cx="566928" cy="566928"/>
-          </a:xfrm>
-          <a:prstGeom prst="rect">
-            <a:avLst/>
-          </a:prstGeom>
-          <a:solidFill>
-            <a:srgbClr val="FFFFFF">
-              <a:alpha val="8000"/>
-            </a:srgbClr>
-          </a:solidFill>
-          <a:ln>
-            <a:noFill/>
-          </a:ln>
-          <a:effectLst/>
-        </p:spPr>
-        <p:style>
-          <a:lnRef idx="1">
-            <a:schemeClr val="accent1"/>
-          </a:lnRef>
-          <a:fillRef idx="3">
-            <a:schemeClr val="accent1"/>
-          </a:fillRef>
-          <a:effectRef idx="2">
-            <a:schemeClr val="accent1"/>
-          </a:effectRef>
-          <a:fontRef idx="minor">
-            <a:schemeClr val="lt1"/>
-          </a:fontRef>
-        </p:style>
-        <p:txBody>
-          <a:bodyPr rtlCol="0" anchor="ctr"/>
-          <a:lstStyle/>
-          <a:p>
-            <a:pPr algn="ctr"/>
-          </a:p>
-        </p:txBody>
-      </p:sp>
-      <p:sp>
-        <p:nvSpPr>
-          <p:cNvPr id="6" name="Rectangle 5"/>
-          <p:cNvSpPr/>
-          <p:nvPr/>
-        </p:nvSpPr>
-        <p:spPr>
-          <a:xfrm>
-            <a:off x="1005840" y="4846320"/>
-            <a:ext cx="566928" cy="566928"/>
-          </a:xfrm>
-          <a:prstGeom prst="rect">
-            <a:avLst/>
-          </a:prstGeom>
-          <a:solidFill>
-            <a:srgbClr val="FFFFFF">
-              <a:alpha val="12000"/>
-            </a:srgbClr>
-          </a:solidFill>
-          <a:ln>
-            <a:noFill/>
-          </a:ln>
-          <a:effectLst/>
-        </p:spPr>
-        <p:style>
-          <a:lnRef idx="1">
-            <a:schemeClr val="accent1"/>
-          </a:lnRef>
-          <a:fillRef idx="3">
-            <a:schemeClr val="accent1"/>
-          </a:fillRef>
-          <a:effectRef idx="2">
-            <a:schemeClr val="accent1"/>
-          </a:effectRef>
-          <a:fontRef idx="minor">
-            <a:schemeClr val="lt1"/>
-          </a:fontRef>
-        </p:style>
-        <p:txBody>
-          <a:bodyPr rtlCol="0" anchor="ctr"/>
-          <a:lstStyle/>
-          <a:p>
-            <a:pPr algn="ctr"/>
-          </a:p>
-        </p:txBody>
-      </p:sp>
-      <p:sp>
-        <p:nvSpPr>
-          <p:cNvPr id="7" name="Rectangle 6"/>
-          <p:cNvSpPr/>
-          <p:nvPr/>
-        </p:nvSpPr>
-        <p:spPr>
-          <a:xfrm>
-            <a:off x="9692640" y="4023360"/>
-            <a:ext cx="566928" cy="566928"/>
-          </a:xfrm>
-          <a:prstGeom prst="rect">
-            <a:avLst/>
-          </a:prstGeom>
-          <a:solidFill>
-            <a:srgbClr val="FFFFFF">
-              <a:alpha val="8000"/>
-            </a:srgbClr>
-          </a:solidFill>
-          <a:ln>
-            <a:noFill/>
-          </a:ln>
-          <a:effectLst/>
-        </p:spPr>
-        <p:style>
-          <a:lnRef idx="1">
-            <a:schemeClr val="accent1"/>
-          </a:lnRef>
-          <a:fillRef idx="3">
-            <a:schemeClr val="accent1"/>
-          </a:fillRef>
-          <a:effectRef idx="2">
-            <a:schemeClr val="accent1"/>
-          </a:effectRef>
-          <a:fontRef idx="minor">
-            <a:schemeClr val="lt1"/>
-          </a:fontRef>
-        </p:style>
-        <p:txBody>
-          <a:bodyPr rtlCol="0" anchor="ctr"/>
-          <a:lstStyle/>
-          <a:p>
-            <a:pPr algn="ctr"/>
-          </a:p>
-        </p:txBody>
-      </p:sp>
-      <p:sp>
-        <p:nvSpPr>
-          <p:cNvPr id="8" name="Rectangle 7"/>
-          <p:cNvSpPr/>
-          <p:nvPr/>
-        </p:nvSpPr>
-        <p:spPr>
-          <a:xfrm>
-            <a:off x="10332720" y="4023360"/>
-            <a:ext cx="566928" cy="566928"/>
-          </a:xfrm>
-          <a:prstGeom prst="rect">
-            <a:avLst/>
-          </a:prstGeom>
-          <a:solidFill>
-            <a:srgbClr val="FFFFFF">
-              <a:alpha val="14000"/>
-            </a:srgbClr>
-          </a:solidFill>
-          <a:ln>
-            <a:noFill/>
-          </a:ln>
-          <a:effectLst/>
-        </p:spPr>
-        <p:style>
-          <a:lnRef idx="1">
-            <a:schemeClr val="accent1"/>
-          </a:lnRef>
-          <a:fillRef idx="3">
-            <a:schemeClr val="accent1"/>
-          </a:fillRef>
-          <a:effectRef idx="2">
-            <a:schemeClr val="accent1"/>
-          </a:effectRef>
-          <a:fontRef idx="minor">
-            <a:schemeClr val="lt1"/>
-          </a:fontRef>
-        </p:style>
-        <p:txBody>
-          <a:bodyPr rtlCol="0" anchor="ctr"/>
-          <a:lstStyle/>
-          <a:p>
-            <a:pPr algn="ctr"/>
-          </a:p>
-        </p:txBody>
-      </p:sp>
-      <p:sp>
-        <p:nvSpPr>
-          <p:cNvPr id="9" name="Rectangle 8"/>
-          <p:cNvSpPr/>
-          <p:nvPr/>
-        </p:nvSpPr>
-        <p:spPr>
-          <a:xfrm>
-            <a:off x="10332720" y="4663440"/>
-            <a:ext cx="566928" cy="566928"/>
-          </a:xfrm>
-          <a:prstGeom prst="rect">
-            <a:avLst/>
-          </a:prstGeom>
-          <a:solidFill>
-            <a:srgbClr val="FFFFFF">
-              <a:alpha val="8000"/>
-            </a:srgbClr>
-          </a:solidFill>
-          <a:ln>
-            <a:noFill/>
-          </a:ln>
-          <a:effectLst/>
-        </p:spPr>
-        <p:style>
-          <a:lnRef idx="1">
-            <a:schemeClr val="accent1"/>
-          </a:lnRef>
-          <a:fillRef idx="3">
-            <a:schemeClr val="accent1"/>
-          </a:fillRef>
-          <a:effectRef idx="2">
-            <a:schemeClr val="accent1"/>
-          </a:effectRef>
-          <a:fontRef idx="minor">
-            <a:schemeClr val="lt1"/>
-          </a:fontRef>
-        </p:style>
-        <p:txBody>
-          <a:bodyPr rtlCol="0" anchor="ctr"/>
-          <a:lstStyle/>
-          <a:p>
-            <a:pPr algn="ctr"/>
-          </a:p>
-        </p:txBody>
-      </p:sp>
-      <p:sp>
-        <p:nvSpPr>
-          <p:cNvPr id="10" name="Rectangle 9"/>
-          <p:cNvSpPr/>
-          <p:nvPr/>
-        </p:nvSpPr>
-        <p:spPr>
-          <a:xfrm>
-            <a:off x="0" y="5577840"/>
-            <a:ext cx="7315200" cy="45720"/>
-          </a:xfrm>
-          <a:prstGeom prst="rect">
-            <a:avLst/>
-          </a:prstGeom>
-          <a:solidFill>
-            <a:srgbClr val="4FA3DC"/>
-          </a:solidFill>
-          <a:ln>
-            <a:noFill/>
-          </a:ln>
-          <a:effectLst/>
-        </p:spPr>
-        <p:style>
-          <a:lnRef idx="1">
-            <a:schemeClr val="accent1"/>
-          </a:lnRef>
-          <a:fillRef idx="3">
-            <a:schemeClr val="accent1"/>
-          </a:fillRef>
-          <a:effectRef idx="2">
-            <a:schemeClr val="accent1"/>
-          </a:effectRef>
-          <a:fontRef idx="minor">
-            <a:schemeClr val="lt1"/>
-          </a:fontRef>
-        </p:style>
-        <p:txBody>
-          <a:bodyPr rtlCol="0" anchor="ctr"/>
-          <a:lstStyle/>
-          <a:p>
-            <a:pPr algn="ctr"/>
-          </a:p>
-        </p:txBody>
-      </p:sp>
-      <p:sp>
-        <p:nvSpPr>
-          <p:cNvPr id="11" name="Rectangle 10"/>
-          <p:cNvSpPr/>
-          <p:nvPr/>
-        </p:nvSpPr>
-        <p:spPr>
-          <a:xfrm>
-            <a:off x="7360920" y="5577840"/>
-            <a:ext cx="320040" cy="45720"/>
-          </a:xfrm>
-          <a:prstGeom prst="rect">
-            <a:avLst/>
-          </a:prstGeom>
-          <a:solidFill>
-            <a:srgbClr val="FFFFFF"/>
-          </a:solidFill>
-          <a:ln>
-            <a:noFill/>
-          </a:ln>
-          <a:effectLst/>
-        </p:spPr>
-        <p:style>
-          <a:lnRef idx="1">
-            <a:schemeClr val="accent1"/>
-          </a:lnRef>
-          <a:fillRef idx="3">
-            <a:schemeClr val="accent1"/>
-          </a:fillRef>
-          <a:effectRef idx="2">
-            <a:schemeClr val="accent1"/>
-          </a:effectRef>
-          <a:fontRef idx="minor">
-            <a:schemeClr val="lt1"/>
-          </a:fontRef>
-        </p:style>
-        <p:txBody>
-          <a:bodyPr rtlCol="0" anchor="ctr"/>
-          <a:lstStyle/>
-          <a:p>
-            <a:pPr algn="ctr"/>
-          </a:p>
-        </p:txBody>
-      </p:sp>
-      <p:sp>
-        <p:nvSpPr>
-          <p:cNvPr id="12" name="Rectangle 11"/>
-          <p:cNvSpPr/>
-          <p:nvPr/>
-        </p:nvSpPr>
-        <p:spPr>
-          <a:xfrm>
-            <a:off x="12027103" y="0"/>
-            <a:ext cx="36576" cy="6858000"/>
-          </a:xfrm>
-          <a:prstGeom prst="rect">
-            <a:avLst/>
-          </a:prstGeom>
-          <a:solidFill>
-            <a:srgbClr val="4FA3DC"/>
-          </a:solidFill>
-          <a:ln>
-            <a:noFill/>
-          </a:ln>
-          <a:effectLst/>
-        </p:spPr>
-        <p:style>
-          <a:lnRef idx="1">
-            <a:schemeClr val="accent1"/>
-          </a:lnRef>
-          <a:fillRef idx="3">
-            <a:schemeClr val="accent1"/>
-          </a:fillRef>
-          <a:effectRef idx="2">
-            <a:schemeClr val="accent1"/>
-          </a:effectRef>
-          <a:fontRef idx="minor">
-            <a:schemeClr val="lt1"/>
-          </a:fontRef>
-        </p:style>
-        <p:txBody>
-          <a:bodyPr rtlCol="0" anchor="ctr"/>
-          <a:lstStyle/>
-          <a:p>
-            <a:pPr algn="ctr"/>
-          </a:p>
-        </p:txBody>
-      </p:sp>
-      <p:sp>
-        <p:nvSpPr>
-          <p:cNvPr id="13" name="Rectangle 12"/>
-          <p:cNvSpPr/>
-          <p:nvPr/>
-        </p:nvSpPr>
-        <p:spPr>
-          <a:xfrm>
-            <a:off x="12118543" y="0"/>
-            <a:ext cx="36576" cy="6858000"/>
-          </a:xfrm>
-          <a:prstGeom prst="rect">
-            <a:avLst/>
-          </a:prstGeom>
-          <a:solidFill>
-            <a:srgbClr val="4FA3DC"/>
-          </a:solidFill>
-          <a:ln>
-            <a:noFill/>
-          </a:ln>
-          <a:effectLst/>
-        </p:spPr>
-        <p:style>
-          <a:lnRef idx="1">
-            <a:schemeClr val="accent1"/>
-          </a:lnRef>
-          <a:fillRef idx="3">
-            <a:schemeClr val="accent1"/>
-          </a:fillRef>
-          <a:effectRef idx="2">
-            <a:schemeClr val="accent1"/>
-          </a:effectRef>
-          <a:fontRef idx="minor">
-            <a:schemeClr val="lt1"/>
-          </a:fontRef>
-        </p:style>
-        <p:txBody>
-          <a:bodyPr rtlCol="0" anchor="ctr"/>
-          <a:lstStyle/>
-          <a:p>
-            <a:pPr algn="ctr"/>
-          </a:p>
-        </p:txBody>
-      </p:sp>
-      <p:sp>
-        <p:nvSpPr>
-          <p:cNvPr id="14" name="TextBox 13"/>
-          <p:cNvSpPr txBox="1"/>
-          <p:nvPr/>
-        </p:nvSpPr>
-        <p:spPr>
-          <a:xfrm>
-            <a:off x="2011680" y="2377440"/>
-            <a:ext cx="8229600" cy="1097280"/>
-          </a:xfrm>
-          <a:prstGeom prst="rect">
-            <a:avLst/>
-          </a:prstGeom>
-          <a:noFill/>
-        </p:spPr>
-        <p:txBody>
-          <a:bodyPr wrap="square" lIns="0" rIns="0" tIns="0" bIns="0" anchor="b">
-            <a:spAutoFit/>
-          </a:bodyPr>
-          <a:lstStyle/>
-          <a:p>
-            <a:pPr algn="l"/>
-            <a:r>
-              <a:rPr sz="4000" b="1">
-                <a:solidFill>
-                  <a:srgbClr val="FFFFFF"/>
-                </a:solidFill>
-                <a:latin typeface="Calibri"/>
-              </a:rPr>
-              <a:t>Bölüm başlığı</a:t>
-            </a:r>
-          </a:p>
-        </p:txBody>
-      </p:sp>
-      <p:sp>
-        <p:nvSpPr>
-          <p:cNvPr id="15" name="TextBox 14"/>
-          <p:cNvSpPr txBox="1"/>
-          <p:nvPr/>
-        </p:nvSpPr>
-        <p:spPr>
-          <a:xfrm>
-            <a:off x="2011680" y="3566160"/>
-            <a:ext cx="8229600" cy="457200"/>
-          </a:xfrm>
-          <a:prstGeom prst="rect">
-            <a:avLst/>
-          </a:prstGeom>
-          <a:noFill/>
-        </p:spPr>
-        <p:txBody>
-          <a:bodyPr wrap="square" lIns="0" rIns="0" tIns="0" bIns="0" anchor="ctr">
-            <a:spAutoFit/>
-          </a:bodyPr>
-          <a:lstStyle/>
-          <a:p>
-            <a:pPr algn="l"/>
-            <a:r>
-              <a:rPr sz="2000" b="0">
-                <a:solidFill>
-                  <a:srgbClr val="F2D7DC"/>
-                </a:solidFill>
-                <a:latin typeface="Calibri"/>
-              </a:rPr>
-              <a:t>Alt başlık</a:t>
-            </a:r>
-          </a:p>
-        </p:txBody>
-      </p:sp>
-    </p:spTree>
-  </p:cSld>
-  <p:clrMapOvr>
-    <a:masterClrMapping/>
-  </p:clrMapOvr>
-</p:sld>
-</file>
-
 <file path=ppt/slides/slide2.xml><?xml version="1.0" encoding="utf-8"?>
 <p:sld xmlns:a="http://schemas.openxmlformats.org/drawingml/2006/main" xmlns:p="http://schemas.openxmlformats.org/presentationml/2006/main" xmlns:r="http://schemas.openxmlformats.org/officeDocument/2006/relationships">
   <p:cSld>
@@ -4765,6 +4125,646 @@
                 <a:latin typeface="Calibri"/>
               </a:rPr>
               <a:t>Slayt başlığı</a:t>
+            </a:r>
+          </a:p>
+        </p:txBody>
+      </p:sp>
+    </p:spTree>
+  </p:cSld>
+  <p:clrMapOvr>
+    <a:masterClrMapping/>
+  </p:clrMapOvr>
+</p:sld>
+</file>
+
+<file path=ppt/slides/slide3.xml><?xml version="1.0" encoding="utf-8"?>
+<p:sld xmlns:a="http://schemas.openxmlformats.org/drawingml/2006/main" xmlns:p="http://schemas.openxmlformats.org/presentationml/2006/main" xmlns:r="http://schemas.openxmlformats.org/officeDocument/2006/relationships">
+  <p:cSld>
+    <p:bg>
+      <p:bgPr>
+        <a:solidFill>
+          <a:srgbClr val="6E1023"/>
+        </a:solidFill>
+        <a:effectLst/>
+      </p:bgPr>
+    </p:bg>
+    <p:spTree>
+      <p:nvGrpSpPr>
+        <p:cNvPr id="1" name=""/>
+        <p:cNvGrpSpPr/>
+        <p:nvPr/>
+      </p:nvGrpSpPr>
+      <p:grpSpPr/>
+      <p:sp>
+        <p:nvSpPr>
+          <p:cNvPr id="2" name="Rectangle 1"/>
+          <p:cNvSpPr/>
+          <p:nvPr/>
+        </p:nvSpPr>
+        <p:spPr>
+          <a:xfrm>
+            <a:off x="365760" y="1097280"/>
+            <a:ext cx="566928" cy="566928"/>
+          </a:xfrm>
+          <a:prstGeom prst="rect">
+            <a:avLst/>
+          </a:prstGeom>
+          <a:solidFill>
+            <a:srgbClr val="FFFFFF">
+              <a:alpha val="10000"/>
+            </a:srgbClr>
+          </a:solidFill>
+          <a:ln>
+            <a:noFill/>
+          </a:ln>
+          <a:effectLst/>
+        </p:spPr>
+        <p:style>
+          <a:lnRef idx="1">
+            <a:schemeClr val="accent1"/>
+          </a:lnRef>
+          <a:fillRef idx="3">
+            <a:schemeClr val="accent1"/>
+          </a:fillRef>
+          <a:effectRef idx="2">
+            <a:schemeClr val="accent1"/>
+          </a:effectRef>
+          <a:fontRef idx="minor">
+            <a:schemeClr val="lt1"/>
+          </a:fontRef>
+        </p:style>
+        <p:txBody>
+          <a:bodyPr rtlCol="0" anchor="ctr"/>
+          <a:lstStyle/>
+          <a:p>
+            <a:pPr algn="ctr"/>
+          </a:p>
+        </p:txBody>
+      </p:sp>
+      <p:sp>
+        <p:nvSpPr>
+          <p:cNvPr id="3" name="Rectangle 2"/>
+          <p:cNvSpPr/>
+          <p:nvPr/>
+        </p:nvSpPr>
+        <p:spPr>
+          <a:xfrm>
+            <a:off x="365760" y="1737360"/>
+            <a:ext cx="566928" cy="566928"/>
+          </a:xfrm>
+          <a:prstGeom prst="rect">
+            <a:avLst/>
+          </a:prstGeom>
+          <a:solidFill>
+            <a:srgbClr val="FFFFFF">
+              <a:alpha val="16000"/>
+            </a:srgbClr>
+          </a:solidFill>
+          <a:ln>
+            <a:noFill/>
+          </a:ln>
+          <a:effectLst/>
+        </p:spPr>
+        <p:style>
+          <a:lnRef idx="1">
+            <a:schemeClr val="accent1"/>
+          </a:lnRef>
+          <a:fillRef idx="3">
+            <a:schemeClr val="accent1"/>
+          </a:fillRef>
+          <a:effectRef idx="2">
+            <a:schemeClr val="accent1"/>
+          </a:effectRef>
+          <a:fontRef idx="minor">
+            <a:schemeClr val="lt1"/>
+          </a:fontRef>
+        </p:style>
+        <p:txBody>
+          <a:bodyPr rtlCol="0" anchor="ctr"/>
+          <a:lstStyle/>
+          <a:p>
+            <a:pPr algn="ctr"/>
+          </a:p>
+        </p:txBody>
+      </p:sp>
+      <p:sp>
+        <p:nvSpPr>
+          <p:cNvPr id="4" name="Rectangle 3"/>
+          <p:cNvSpPr/>
+          <p:nvPr/>
+        </p:nvSpPr>
+        <p:spPr>
+          <a:xfrm>
+            <a:off x="1005840" y="1737360"/>
+            <a:ext cx="566928" cy="566928"/>
+          </a:xfrm>
+          <a:prstGeom prst="rect">
+            <a:avLst/>
+          </a:prstGeom>
+          <a:solidFill>
+            <a:srgbClr val="FFFFFF">
+              <a:alpha val="8000"/>
+            </a:srgbClr>
+          </a:solidFill>
+          <a:ln>
+            <a:noFill/>
+          </a:ln>
+          <a:effectLst/>
+        </p:spPr>
+        <p:style>
+          <a:lnRef idx="1">
+            <a:schemeClr val="accent1"/>
+          </a:lnRef>
+          <a:fillRef idx="3">
+            <a:schemeClr val="accent1"/>
+          </a:fillRef>
+          <a:effectRef idx="2">
+            <a:schemeClr val="accent1"/>
+          </a:effectRef>
+          <a:fontRef idx="minor">
+            <a:schemeClr val="lt1"/>
+          </a:fontRef>
+        </p:style>
+        <p:txBody>
+          <a:bodyPr rtlCol="0" anchor="ctr"/>
+          <a:lstStyle/>
+          <a:p>
+            <a:pPr algn="ctr"/>
+          </a:p>
+        </p:txBody>
+      </p:sp>
+      <p:sp>
+        <p:nvSpPr>
+          <p:cNvPr id="5" name="Rectangle 4"/>
+          <p:cNvSpPr/>
+          <p:nvPr/>
+        </p:nvSpPr>
+        <p:spPr>
+          <a:xfrm>
+            <a:off x="365760" y="4206240"/>
+            <a:ext cx="566928" cy="566928"/>
+          </a:xfrm>
+          <a:prstGeom prst="rect">
+            <a:avLst/>
+          </a:prstGeom>
+          <a:solidFill>
+            <a:srgbClr val="FFFFFF">
+              <a:alpha val="8000"/>
+            </a:srgbClr>
+          </a:solidFill>
+          <a:ln>
+            <a:noFill/>
+          </a:ln>
+          <a:effectLst/>
+        </p:spPr>
+        <p:style>
+          <a:lnRef idx="1">
+            <a:schemeClr val="accent1"/>
+          </a:lnRef>
+          <a:fillRef idx="3">
+            <a:schemeClr val="accent1"/>
+          </a:fillRef>
+          <a:effectRef idx="2">
+            <a:schemeClr val="accent1"/>
+          </a:effectRef>
+          <a:fontRef idx="minor">
+            <a:schemeClr val="lt1"/>
+          </a:fontRef>
+        </p:style>
+        <p:txBody>
+          <a:bodyPr rtlCol="0" anchor="ctr"/>
+          <a:lstStyle/>
+          <a:p>
+            <a:pPr algn="ctr"/>
+          </a:p>
+        </p:txBody>
+      </p:sp>
+      <p:sp>
+        <p:nvSpPr>
+          <p:cNvPr id="6" name="Rectangle 5"/>
+          <p:cNvSpPr/>
+          <p:nvPr/>
+        </p:nvSpPr>
+        <p:spPr>
+          <a:xfrm>
+            <a:off x="1005840" y="4846320"/>
+            <a:ext cx="566928" cy="566928"/>
+          </a:xfrm>
+          <a:prstGeom prst="rect">
+            <a:avLst/>
+          </a:prstGeom>
+          <a:solidFill>
+            <a:srgbClr val="FFFFFF">
+              <a:alpha val="12000"/>
+            </a:srgbClr>
+          </a:solidFill>
+          <a:ln>
+            <a:noFill/>
+          </a:ln>
+          <a:effectLst/>
+        </p:spPr>
+        <p:style>
+          <a:lnRef idx="1">
+            <a:schemeClr val="accent1"/>
+          </a:lnRef>
+          <a:fillRef idx="3">
+            <a:schemeClr val="accent1"/>
+          </a:fillRef>
+          <a:effectRef idx="2">
+            <a:schemeClr val="accent1"/>
+          </a:effectRef>
+          <a:fontRef idx="minor">
+            <a:schemeClr val="lt1"/>
+          </a:fontRef>
+        </p:style>
+        <p:txBody>
+          <a:bodyPr rtlCol="0" anchor="ctr"/>
+          <a:lstStyle/>
+          <a:p>
+            <a:pPr algn="ctr"/>
+          </a:p>
+        </p:txBody>
+      </p:sp>
+      <p:sp>
+        <p:nvSpPr>
+          <p:cNvPr id="7" name="Rectangle 6"/>
+          <p:cNvSpPr/>
+          <p:nvPr/>
+        </p:nvSpPr>
+        <p:spPr>
+          <a:xfrm>
+            <a:off x="9692640" y="4023360"/>
+            <a:ext cx="566928" cy="566928"/>
+          </a:xfrm>
+          <a:prstGeom prst="rect">
+            <a:avLst/>
+          </a:prstGeom>
+          <a:solidFill>
+            <a:srgbClr val="FFFFFF">
+              <a:alpha val="8000"/>
+            </a:srgbClr>
+          </a:solidFill>
+          <a:ln>
+            <a:noFill/>
+          </a:ln>
+          <a:effectLst/>
+        </p:spPr>
+        <p:style>
+          <a:lnRef idx="1">
+            <a:schemeClr val="accent1"/>
+          </a:lnRef>
+          <a:fillRef idx="3">
+            <a:schemeClr val="accent1"/>
+          </a:fillRef>
+          <a:effectRef idx="2">
+            <a:schemeClr val="accent1"/>
+          </a:effectRef>
+          <a:fontRef idx="minor">
+            <a:schemeClr val="lt1"/>
+          </a:fontRef>
+        </p:style>
+        <p:txBody>
+          <a:bodyPr rtlCol="0" anchor="ctr"/>
+          <a:lstStyle/>
+          <a:p>
+            <a:pPr algn="ctr"/>
+          </a:p>
+        </p:txBody>
+      </p:sp>
+      <p:sp>
+        <p:nvSpPr>
+          <p:cNvPr id="8" name="Rectangle 7"/>
+          <p:cNvSpPr/>
+          <p:nvPr/>
+        </p:nvSpPr>
+        <p:spPr>
+          <a:xfrm>
+            <a:off x="10332720" y="4023360"/>
+            <a:ext cx="566928" cy="566928"/>
+          </a:xfrm>
+          <a:prstGeom prst="rect">
+            <a:avLst/>
+          </a:prstGeom>
+          <a:solidFill>
+            <a:srgbClr val="FFFFFF">
+              <a:alpha val="14000"/>
+            </a:srgbClr>
+          </a:solidFill>
+          <a:ln>
+            <a:noFill/>
+          </a:ln>
+          <a:effectLst/>
+        </p:spPr>
+        <p:style>
+          <a:lnRef idx="1">
+            <a:schemeClr val="accent1"/>
+          </a:lnRef>
+          <a:fillRef idx="3">
+            <a:schemeClr val="accent1"/>
+          </a:fillRef>
+          <a:effectRef idx="2">
+            <a:schemeClr val="accent1"/>
+          </a:effectRef>
+          <a:fontRef idx="minor">
+            <a:schemeClr val="lt1"/>
+          </a:fontRef>
+        </p:style>
+        <p:txBody>
+          <a:bodyPr rtlCol="0" anchor="ctr"/>
+          <a:lstStyle/>
+          <a:p>
+            <a:pPr algn="ctr"/>
+          </a:p>
+        </p:txBody>
+      </p:sp>
+      <p:sp>
+        <p:nvSpPr>
+          <p:cNvPr id="9" name="Rectangle 8"/>
+          <p:cNvSpPr/>
+          <p:nvPr/>
+        </p:nvSpPr>
+        <p:spPr>
+          <a:xfrm>
+            <a:off x="10332720" y="4663440"/>
+            <a:ext cx="566928" cy="566928"/>
+          </a:xfrm>
+          <a:prstGeom prst="rect">
+            <a:avLst/>
+          </a:prstGeom>
+          <a:solidFill>
+            <a:srgbClr val="FFFFFF">
+              <a:alpha val="8000"/>
+            </a:srgbClr>
+          </a:solidFill>
+          <a:ln>
+            <a:noFill/>
+          </a:ln>
+          <a:effectLst/>
+        </p:spPr>
+        <p:style>
+          <a:lnRef idx="1">
+            <a:schemeClr val="accent1"/>
+          </a:lnRef>
+          <a:fillRef idx="3">
+            <a:schemeClr val="accent1"/>
+          </a:fillRef>
+          <a:effectRef idx="2">
+            <a:schemeClr val="accent1"/>
+          </a:effectRef>
+          <a:fontRef idx="minor">
+            <a:schemeClr val="lt1"/>
+          </a:fontRef>
+        </p:style>
+        <p:txBody>
+          <a:bodyPr rtlCol="0" anchor="ctr"/>
+          <a:lstStyle/>
+          <a:p>
+            <a:pPr algn="ctr"/>
+          </a:p>
+        </p:txBody>
+      </p:sp>
+      <p:sp>
+        <p:nvSpPr>
+          <p:cNvPr id="10" name="Rectangle 9"/>
+          <p:cNvSpPr/>
+          <p:nvPr/>
+        </p:nvSpPr>
+        <p:spPr>
+          <a:xfrm>
+            <a:off x="0" y="5577840"/>
+            <a:ext cx="7315200" cy="45720"/>
+          </a:xfrm>
+          <a:prstGeom prst="rect">
+            <a:avLst/>
+          </a:prstGeom>
+          <a:solidFill>
+            <a:srgbClr val="4FA3DC"/>
+          </a:solidFill>
+          <a:ln>
+            <a:noFill/>
+          </a:ln>
+          <a:effectLst/>
+        </p:spPr>
+        <p:style>
+          <a:lnRef idx="1">
+            <a:schemeClr val="accent1"/>
+          </a:lnRef>
+          <a:fillRef idx="3">
+            <a:schemeClr val="accent1"/>
+          </a:fillRef>
+          <a:effectRef idx="2">
+            <a:schemeClr val="accent1"/>
+          </a:effectRef>
+          <a:fontRef idx="minor">
+            <a:schemeClr val="lt1"/>
+          </a:fontRef>
+        </p:style>
+        <p:txBody>
+          <a:bodyPr rtlCol="0" anchor="ctr"/>
+          <a:lstStyle/>
+          <a:p>
+            <a:pPr algn="ctr"/>
+          </a:p>
+        </p:txBody>
+      </p:sp>
+      <p:sp>
+        <p:nvSpPr>
+          <p:cNvPr id="11" name="Rectangle 10"/>
+          <p:cNvSpPr/>
+          <p:nvPr/>
+        </p:nvSpPr>
+        <p:spPr>
+          <a:xfrm>
+            <a:off x="7360920" y="5577840"/>
+            <a:ext cx="320040" cy="45720"/>
+          </a:xfrm>
+          <a:prstGeom prst="rect">
+            <a:avLst/>
+          </a:prstGeom>
+          <a:solidFill>
+            <a:srgbClr val="FFFFFF"/>
+          </a:solidFill>
+          <a:ln>
+            <a:noFill/>
+          </a:ln>
+          <a:effectLst/>
+        </p:spPr>
+        <p:style>
+          <a:lnRef idx="1">
+            <a:schemeClr val="accent1"/>
+          </a:lnRef>
+          <a:fillRef idx="3">
+            <a:schemeClr val="accent1"/>
+          </a:fillRef>
+          <a:effectRef idx="2">
+            <a:schemeClr val="accent1"/>
+          </a:effectRef>
+          <a:fontRef idx="minor">
+            <a:schemeClr val="lt1"/>
+          </a:fontRef>
+        </p:style>
+        <p:txBody>
+          <a:bodyPr rtlCol="0" anchor="ctr"/>
+          <a:lstStyle/>
+          <a:p>
+            <a:pPr algn="ctr"/>
+          </a:p>
+        </p:txBody>
+      </p:sp>
+      <p:sp>
+        <p:nvSpPr>
+          <p:cNvPr id="12" name="Rectangle 11"/>
+          <p:cNvSpPr/>
+          <p:nvPr/>
+        </p:nvSpPr>
+        <p:spPr>
+          <a:xfrm>
+            <a:off x="12027103" y="0"/>
+            <a:ext cx="36576" cy="6858000"/>
+          </a:xfrm>
+          <a:prstGeom prst="rect">
+            <a:avLst/>
+          </a:prstGeom>
+          <a:solidFill>
+            <a:srgbClr val="4FA3DC"/>
+          </a:solidFill>
+          <a:ln>
+            <a:noFill/>
+          </a:ln>
+          <a:effectLst/>
+        </p:spPr>
+        <p:style>
+          <a:lnRef idx="1">
+            <a:schemeClr val="accent1"/>
+          </a:lnRef>
+          <a:fillRef idx="3">
+            <a:schemeClr val="accent1"/>
+          </a:fillRef>
+          <a:effectRef idx="2">
+            <a:schemeClr val="accent1"/>
+          </a:effectRef>
+          <a:fontRef idx="minor">
+            <a:schemeClr val="lt1"/>
+          </a:fontRef>
+        </p:style>
+        <p:txBody>
+          <a:bodyPr rtlCol="0" anchor="ctr"/>
+          <a:lstStyle/>
+          <a:p>
+            <a:pPr algn="ctr"/>
+          </a:p>
+        </p:txBody>
+      </p:sp>
+      <p:sp>
+        <p:nvSpPr>
+          <p:cNvPr id="13" name="Rectangle 12"/>
+          <p:cNvSpPr/>
+          <p:nvPr/>
+        </p:nvSpPr>
+        <p:spPr>
+          <a:xfrm>
+            <a:off x="12118543" y="0"/>
+            <a:ext cx="36576" cy="6858000"/>
+          </a:xfrm>
+          <a:prstGeom prst="rect">
+            <a:avLst/>
+          </a:prstGeom>
+          <a:solidFill>
+            <a:srgbClr val="4FA3DC"/>
+          </a:solidFill>
+          <a:ln>
+            <a:noFill/>
+          </a:ln>
+          <a:effectLst/>
+        </p:spPr>
+        <p:style>
+          <a:lnRef idx="1">
+            <a:schemeClr val="accent1"/>
+          </a:lnRef>
+          <a:fillRef idx="3">
+            <a:schemeClr val="accent1"/>
+          </a:fillRef>
+          <a:effectRef idx="2">
+            <a:schemeClr val="accent1"/>
+          </a:effectRef>
+          <a:fontRef idx="minor">
+            <a:schemeClr val="lt1"/>
+          </a:fontRef>
+        </p:style>
+        <p:txBody>
+          <a:bodyPr rtlCol="0" anchor="ctr"/>
+          <a:lstStyle/>
+          <a:p>
+            <a:pPr algn="ctr"/>
+          </a:p>
+        </p:txBody>
+      </p:sp>
+      <p:sp>
+        <p:nvSpPr>
+          <p:cNvPr id="14" name="TextBox 13"/>
+          <p:cNvSpPr txBox="1"/>
+          <p:nvPr/>
+        </p:nvSpPr>
+        <p:spPr>
+          <a:xfrm>
+            <a:off x="2011680" y="2377440"/>
+            <a:ext cx="8229600" cy="1097280"/>
+          </a:xfrm>
+          <a:prstGeom prst="rect">
+            <a:avLst/>
+          </a:prstGeom>
+          <a:noFill/>
+        </p:spPr>
+        <p:txBody>
+          <a:bodyPr wrap="square" lIns="0" rIns="0" tIns="0" bIns="0" anchor="b">
+            <a:spAutoFit/>
+          </a:bodyPr>
+          <a:lstStyle/>
+          <a:p>
+            <a:pPr algn="l"/>
+            <a:r>
+              <a:rPr sz="4000" b="1">
+                <a:solidFill>
+                  <a:srgbClr val="FFFFFF"/>
+                </a:solidFill>
+                <a:latin typeface="Calibri"/>
+              </a:rPr>
+              <a:t>Bölüm başlığı</a:t>
+            </a:r>
+          </a:p>
+        </p:txBody>
+      </p:sp>
+      <p:sp>
+        <p:nvSpPr>
+          <p:cNvPr id="15" name="TextBox 14"/>
+          <p:cNvSpPr txBox="1"/>
+          <p:nvPr/>
+        </p:nvSpPr>
+        <p:spPr>
+          <a:xfrm>
+            <a:off x="2011680" y="3566160"/>
+            <a:ext cx="8229600" cy="457200"/>
+          </a:xfrm>
+          <a:prstGeom prst="rect">
+            <a:avLst/>
+          </a:prstGeom>
+          <a:noFill/>
+        </p:spPr>
+        <p:txBody>
+          <a:bodyPr wrap="square" lIns="0" rIns="0" tIns="0" bIns="0" anchor="ctr">
+            <a:spAutoFit/>
+          </a:bodyPr>
+          <a:lstStyle/>
+          <a:p>
+            <a:pPr algn="l"/>
+            <a:r>
+              <a:rPr sz="2000" b="0">
+                <a:solidFill>
+                  <a:srgbClr val="F2D7DC"/>
+                </a:solidFill>
+                <a:latin typeface="Calibri"/>
+              </a:rPr>
+              <a:t>Alt başlık</a:t>
             </a:r>
           </a:p>
         </p:txBody>

</xml_diff>